<commit_message>
Update PowerPoint for song #239 in FUBC - Українські
</commit_message>
<xml_diff>
--- a/fubc-ua/239-Я не свій! Христом спасенний! (Пісні Спасенних №238).pptx
+++ b/fubc-ua/239-Я не свій! Христом спасенний! (Пісні Спасенних №238).pptx
@@ -1951,7 +1951,7 @@
                 <a:ea typeface="Arial" pitchFamily="34" charset="-122"/>
                 <a:cs typeface="Arial" pitchFamily="34" charset="-120"/>
               </a:rPr>
-              <a:t>Я Твій! (Я Твій!) Я Твій! (Я Твій!)</a:t>
+              <a:t>Я Твій! Я Твій!</a:t>
             </a:r>
             <a:endParaRPr lang="en-US" sz="5200" dirty="0"/>
           </a:p>
@@ -2195,7 +2195,7 @@
                 <a:ea typeface="Arial" pitchFamily="34" charset="-122"/>
                 <a:cs typeface="Arial" pitchFamily="34" charset="-120"/>
               </a:rPr>
-              <a:t>Я Твій! (Я Твій!) Я Твій! (Я Твій!)</a:t>
+              <a:t>Я Твій! Я Твій!</a:t>
             </a:r>
             <a:endParaRPr lang="en-US" sz="5200" dirty="0"/>
           </a:p>
@@ -2439,7 +2439,7 @@
                 <a:ea typeface="Arial" pitchFamily="34" charset="-122"/>
                 <a:cs typeface="Arial" pitchFamily="34" charset="-120"/>
               </a:rPr>
-              <a:t>Я Твій! (Я Твій!) Я Твій! (Я Твій!)</a:t>
+              <a:t>Я Твій! Я Твій!</a:t>
             </a:r>
             <a:endParaRPr lang="en-US" sz="5200" dirty="0"/>
           </a:p>
@@ -2683,7 +2683,7 @@
                 <a:ea typeface="Arial" pitchFamily="34" charset="-122"/>
                 <a:cs typeface="Arial" pitchFamily="34" charset="-120"/>
               </a:rPr>
-              <a:t>Я Твій! (Я Твій!) Я Твій! (Я Твій!)</a:t>
+              <a:t>Я Твій! Я Твій!</a:t>
             </a:r>
             <a:endParaRPr lang="en-US" sz="5200" dirty="0"/>
           </a:p>

</xml_diff>